<commit_message>
Harden the finals deck and complete macaw branding
</commit_message>
<xml_diff>
--- a/docs/presentation/Talk-Active_RISTEK_Finals_2026.pptx
+++ b/docs/presentation/Talk-Active_RISTEK_Finals_2026.pptx
@@ -1333,7 +1333,7 @@
             <a:r>
               <a:rPr lang="en-US" dirty="0"/>
               <a:t>TIMING 5:50–6:15
-Production reality matters. The current submission passes 147 automated tests, 17 real-browser checks, and a 16-stage demo gate with zero console errors. AI spend is capped at five dollars with no auto-refresh and alerts at 50, 75 and 100 percent. Based on the actual primary model and our prompt size, one analysis is estimated at 0.27 to 0.6 cents; repeated demo inputs come from cache at zero additional model cost. If the cap or network fails, the deterministic path remains.
+Production reality matters. The current submission passes more than 150 automated tests, 18 real-browser checks, and a 16-stage demo gate with zero console errors. AI spend is capped at five dollars with no auto-refresh and alerts at 50, 75 and 100 percent. Based on the actual primary model and our prompt size, one analysis is estimated at 0.27 to 0.6 cents; repeated demo inputs come from cache at zero additional model cost. If the cap or network fails, the deterministic path remains.
 CUE: “What is built today—and what comes next—is equally explicit.”
 OPERATOR: advance only on the presenter's final cue.</a:t>
             </a:r>
@@ -10357,7 +10357,7 @@
                 <a:ea typeface="Aptos" pitchFamily="34" charset="-122"/>
                 <a:cs typeface="Aptos" pitchFamily="34" charset="-120"/>
               </a:rPr>
-              <a:t>147</a:t>
+              <a:t>150+</a:t>
             </a:r>
             <a:endParaRPr lang="en-US" sz="3800" dirty="0"/>
           </a:p>
@@ -10507,7 +10507,7 @@
                 <a:ea typeface="Aptos" pitchFamily="34" charset="-122"/>
                 <a:cs typeface="Aptos" pitchFamily="34" charset="-120"/>
               </a:rPr>
-              <a:t>17</a:t>
+              <a:t>18</a:t>
             </a:r>
             <a:endParaRPr lang="en-US" sz="3800" dirty="0"/>
           </a:p>

</xml_diff>